<commit_message>
fix: a slide run without a size takes the one its paragraph declares
DrawingML declares run formatting at three levels — the run's `a:rPr`, the
paragraph's `a:pPr/a:defRPr`, and the shape body's `a:lstStyle/a:lvl1pPr/
a:defRPr` — and only the first was read. The NASA deck's closing slide sets
36.07 pt on the paragraph and leaves the runs bare, so its text was drawn at the
generic 18 pt fallback, a little over half size. `a:rPr` also cleared bold and
italic when it omitted them, wiping whatever the level above had set.

  nasa slide 11  geometry 0.0009 -> 0.3107, mean drift 106.58 -> 14.70 px

Co-Authored-By: Claude Opus 5 (1M context) <noreply@anthropic.com>
</commit_message>
<xml_diff>
--- a/fixtures/slide-features.pptx
+++ b/fixtures/slide-features.pptx
@@ -170,6 +170,37 @@
           </a:p>
         </p:txBody>
       </p:sp>
+      <p:sp>
+        <p:nvSpPr>
+          <p:cNvPr id="8" name="Inherited size"/>
+          <p:cNvSpPr/>
+          <p:nvPr/>
+        </p:nvSpPr>
+        <p:spPr>
+          <a:xfrm>
+            <a:off x="914400" y="3657600"/>
+            <a:ext cx="4572000" cy="914400"/>
+          </a:xfrm>
+          <a:prstGeom prst="rect"/>
+        </p:spPr>
+        <p:txBody>
+          <a:bodyPr/>
+          <a:lstStyle>
+            <a:lvl1pPr>
+              <a:defRPr sz="1000"/>
+            </a:lvl1pPr>
+          </a:lstStyle>
+          <a:p>
+            <a:pPr>
+              <a:defRPr sz="3600"/>
+            </a:pPr>
+            <a:r>
+              <a:rPr lang="en-US"/>
+              <a:t>Inherited size</a:t>
+            </a:r>
+          </a:p>
+        </p:txBody>
+      </p:sp>
     </p:spTree>
   </p:cSld>
 </p:sld>

</xml_diff>